<commit_message>
Publica API no Render e registra fluxo HTTPS, acesso e evidências do CP3
</commit_message>
<xml_diff>
--- a/APRESENTACAO_CP3.pptx
+++ b/APRESENTACAO_CP3.pptx
@@ -2,20 +2,20 @@
 <file path=ppt/presentation.xml><?xml version="1.0" encoding="utf-8"?>
 <p:presentation xmlns:p="http://schemas.openxmlformats.org/presentationml/2006/main">
   <p:sldMasterIdLst>
-    <p:sldMasterId xmlns:r="http://schemas.openxmlformats.org/officeDocument/2006/relationships" id="2147483648" r:id="Reedde8efc3b54f35"/>
+    <p:sldMasterId xmlns:r="http://schemas.openxmlformats.org/officeDocument/2006/relationships" id="2147483648" r:id="R9296b91b457d4932"/>
   </p:sldMasterIdLst>
   <p:notesMasterIdLst>
-    <p:notesMasterId xmlns:r="http://schemas.openxmlformats.org/officeDocument/2006/relationships" r:id="R38e95af282144e36"/>
+    <p:notesMasterId xmlns:r="http://schemas.openxmlformats.org/officeDocument/2006/relationships" r:id="R129c5c6a4f934ccd"/>
   </p:notesMasterIdLst>
   <p:sldIdLst>
-    <p:sldId xmlns:r="http://schemas.openxmlformats.org/officeDocument/2006/relationships" id="256" r:id="R30618ad9cceb44a8"/>
-    <p:sldId xmlns:r="http://schemas.openxmlformats.org/officeDocument/2006/relationships" id="257" r:id="Rd4abda54e4e9449f"/>
-    <p:sldId xmlns:r="http://schemas.openxmlformats.org/officeDocument/2006/relationships" id="258" r:id="R6319928e087e4cf0"/>
-    <p:sldId xmlns:r="http://schemas.openxmlformats.org/officeDocument/2006/relationships" id="259" r:id="R02b008806b1c4005"/>
-    <p:sldId xmlns:r="http://schemas.openxmlformats.org/officeDocument/2006/relationships" id="260" r:id="R515e29fc0f7942bc"/>
-    <p:sldId xmlns:r="http://schemas.openxmlformats.org/officeDocument/2006/relationships" id="261" r:id="R1c15172f3dc5410d"/>
-    <p:sldId xmlns:r="http://schemas.openxmlformats.org/officeDocument/2006/relationships" id="262" r:id="R61e933d66e0248fb"/>
-    <p:sldId xmlns:r="http://schemas.openxmlformats.org/officeDocument/2006/relationships" id="263" r:id="Rd624a2419d5547ce"/>
+    <p:sldId xmlns:r="http://schemas.openxmlformats.org/officeDocument/2006/relationships" id="256" r:id="Rdb79de0a6bc14115"/>
+    <p:sldId xmlns:r="http://schemas.openxmlformats.org/officeDocument/2006/relationships" id="257" r:id="Rb96d395597dd4c24"/>
+    <p:sldId xmlns:r="http://schemas.openxmlformats.org/officeDocument/2006/relationships" id="258" r:id="Rf6c60b84b77548e9"/>
+    <p:sldId xmlns:r="http://schemas.openxmlformats.org/officeDocument/2006/relationships" id="259" r:id="R1a36999fd9a949fd"/>
+    <p:sldId xmlns:r="http://schemas.openxmlformats.org/officeDocument/2006/relationships" id="260" r:id="R7c010ab9b0894c0f"/>
+    <p:sldId xmlns:r="http://schemas.openxmlformats.org/officeDocument/2006/relationships" id="261" r:id="Rfa7aa2b936b64850"/>
+    <p:sldId xmlns:r="http://schemas.openxmlformats.org/officeDocument/2006/relationships" id="262" r:id="R00fd8819793740cf"/>
+    <p:sldId xmlns:r="http://schemas.openxmlformats.org/officeDocument/2006/relationships" id="263" r:id="R59aadce4c44a449d"/>
   </p:sldIdLst>
   <p:sldSz cx="12192000" cy="6858000"/>
   <p:notesSz cx="6858000" cy="9144000"/>
@@ -729,7 +729,7 @@
           <a:lstStyle xmlns:a="http://schemas.openxmlformats.org/drawingml/2006/main"/>
           <a:p xmlns:a="http://schemas.openxmlformats.org/drawingml/2006/main">
             <a:r>
-              <a:t>Não confundir a execução temporária do CI com deploy permanente. SQLite em disco efêmero pode perder dados. Ollama exige serviço próprio. Fontes: https://render.com/docs/blueprint-spec e https://render.com/docs/free.</a:t>
+              <a:t>Deploy dep-dbbusbjncjis73fdld60, live em 20/10/2026. Evidências em evidencias/render-deploy.json e deploy-fluxo.json. SQLite em disco efêmero pode perder dados. Ollama exige serviço próprio. Fontes: https://render.com/docs/blueprint-spec e https://render.com/docs/free.</a:t>
             </a:r>
           </a:p>
         </p:txBody>
@@ -869,7 +869,7 @@
           <a:lstStyle xmlns:a="http://schemas.openxmlformats.org/drawingml/2006/main"/>
           <a:p xmlns:a="http://schemas.openxmlformats.org/drawingml/2006/main">
             <a:r>
-              <a:t>Demonstrar 422 e o resultado esperado. No ambiente publicado, executar scripts/smoke.py --exercise com chave no ambiente. Registrar URL real e evidência antes de apresentar deploy como concluído.</a:t>
+              <a:t>Demonstrar 422 e o resultado esperado. No ambiente publicado, o script smoke verificou 12 requisições HTTPS. Usar a chave privada do Render no Swagger. Evidência em evidencias/deploy-fluxo.json.</a:t>
             </a:r>
           </a:p>
         </p:txBody>
@@ -996,7 +996,7 @@
           <p:cNvPr id="3" name="Title">
             <a:extLst xmlns:a="http://schemas.openxmlformats.org/drawingml/2006/main">
               <a:ext uri="{FF2B5EF4-FFF2-40B4-BE49-F238E27FC236}">
-                <a16:creationId xmlns:a16="http://schemas.microsoft.com/office/drawing/2014/main" id="{924D4B49-C08B-42E0-BFBA-3BA64B1D8203}"/>
+                <a16:creationId xmlns:a16="http://schemas.microsoft.com/office/drawing/2014/main" id="{D6679941-7419-4BCB-9EB0-0A8F94C364A1}"/>
               </a:ext>
             </a:extLst>
           </p:cNvPr>
@@ -1225,7 +1225,7 @@
           <p:cNvPr id="2" name="Subtitle">
             <a:extLst xmlns:a="http://schemas.openxmlformats.org/drawingml/2006/main">
               <a:ext uri="{FF2B5EF4-FFF2-40B4-BE49-F238E27FC236}">
-                <a16:creationId xmlns:a16="http://schemas.microsoft.com/office/drawing/2014/main" id="{D12890E0-B827-492B-AB08-031747FE539C}"/>
+                <a16:creationId xmlns:a16="http://schemas.microsoft.com/office/drawing/2014/main" id="{0C5D7FF3-9914-40F6-ABBF-C0A1FFF51340}"/>
               </a:ext>
             </a:extLst>
           </p:cNvPr>
@@ -1471,7 +1471,7 @@
           <p:cNvPr id="2" name="Section title">
             <a:extLst xmlns:a="http://schemas.openxmlformats.org/drawingml/2006/main">
               <a:ext uri="{FF2B5EF4-FFF2-40B4-BE49-F238E27FC236}">
-                <a16:creationId xmlns:a16="http://schemas.microsoft.com/office/drawing/2014/main" id="{A25DCCC9-41DA-4DFB-BCEC-11A2086D7707}"/>
+                <a16:creationId xmlns:a16="http://schemas.microsoft.com/office/drawing/2014/main" id="{6360123F-749B-4C35-85CA-C4041AD6A3C3}"/>
               </a:ext>
             </a:extLst>
           </p:cNvPr>
@@ -1717,7 +1717,7 @@
           <p:cNvPr id="3" name="Title">
             <a:extLst xmlns:a="http://schemas.openxmlformats.org/drawingml/2006/main">
               <a:ext uri="{FF2B5EF4-FFF2-40B4-BE49-F238E27FC236}">
-                <a16:creationId xmlns:a16="http://schemas.microsoft.com/office/drawing/2014/main" id="{196B443C-787F-428D-9346-2CCC377EED23}"/>
+                <a16:creationId xmlns:a16="http://schemas.microsoft.com/office/drawing/2014/main" id="{F9426B25-ECC4-46B9-A349-1C120136B9C7}"/>
               </a:ext>
             </a:extLst>
           </p:cNvPr>
@@ -1946,7 +1946,7 @@
           <p:cNvPr id="2" name="Body">
             <a:extLst xmlns:a="http://schemas.openxmlformats.org/drawingml/2006/main">
               <a:ext uri="{FF2B5EF4-FFF2-40B4-BE49-F238E27FC236}">
-                <a16:creationId xmlns:a16="http://schemas.microsoft.com/office/drawing/2014/main" id="{EB005F35-B8B9-4A02-AF30-CBFD42328DDB}"/>
+                <a16:creationId xmlns:a16="http://schemas.microsoft.com/office/drawing/2014/main" id="{6B8BB494-36F1-4199-BE82-EFBE5D45D18D}"/>
               </a:ext>
             </a:extLst>
           </p:cNvPr>
@@ -2192,7 +2192,7 @@
           <p:cNvPr id="4" name="Title">
             <a:extLst xmlns:a="http://schemas.openxmlformats.org/drawingml/2006/main">
               <a:ext uri="{FF2B5EF4-FFF2-40B4-BE49-F238E27FC236}">
-                <a16:creationId xmlns:a16="http://schemas.microsoft.com/office/drawing/2014/main" id="{EF1AD9C8-A397-4AFF-B6B8-AEB9102C44C1}"/>
+                <a16:creationId xmlns:a16="http://schemas.microsoft.com/office/drawing/2014/main" id="{C54A6C2F-46E5-4439-BDA1-92EAB509A6A9}"/>
               </a:ext>
             </a:extLst>
           </p:cNvPr>
@@ -2421,7 +2421,7 @@
           <p:cNvPr id="2" name="Left column">
             <a:extLst xmlns:a="http://schemas.openxmlformats.org/drawingml/2006/main">
               <a:ext uri="{FF2B5EF4-FFF2-40B4-BE49-F238E27FC236}">
-                <a16:creationId xmlns:a16="http://schemas.microsoft.com/office/drawing/2014/main" id="{1012E930-F06D-401D-BCE0-EB160E9E45F3}"/>
+                <a16:creationId xmlns:a16="http://schemas.microsoft.com/office/drawing/2014/main" id="{D50754E3-92CE-4F8F-BB8A-5EA799BEEDBC}"/>
               </a:ext>
             </a:extLst>
           </p:cNvPr>
@@ -2650,7 +2650,7 @@
           <p:cNvPr id="3" name="Right column">
             <a:extLst xmlns:a="http://schemas.openxmlformats.org/drawingml/2006/main">
               <a:ext uri="{FF2B5EF4-FFF2-40B4-BE49-F238E27FC236}">
-                <a16:creationId xmlns:a16="http://schemas.microsoft.com/office/drawing/2014/main" id="{760BF205-3773-4CFF-9E1B-338D81E4AB41}"/>
+                <a16:creationId xmlns:a16="http://schemas.microsoft.com/office/drawing/2014/main" id="{E1DB32BE-C6AF-4D0E-BA4E-0B096246B014}"/>
               </a:ext>
             </a:extLst>
           </p:cNvPr>
@@ -2896,7 +2896,7 @@
           <p:cNvPr id="3" name="Title">
             <a:extLst xmlns:a="http://schemas.openxmlformats.org/drawingml/2006/main">
               <a:ext uri="{FF2B5EF4-FFF2-40B4-BE49-F238E27FC236}">
-                <a16:creationId xmlns:a16="http://schemas.microsoft.com/office/drawing/2014/main" id="{86458224-2500-471C-82D1-D9FD1583BE41}"/>
+                <a16:creationId xmlns:a16="http://schemas.microsoft.com/office/drawing/2014/main" id="{3DDC0F1E-45B6-45DF-A6F7-207633A2B1DB}"/>
               </a:ext>
             </a:extLst>
           </p:cNvPr>
@@ -3125,7 +3125,7 @@
           <p:cNvPr id="2" name="Left column">
             <a:extLst xmlns:a="http://schemas.openxmlformats.org/drawingml/2006/main">
               <a:ext uri="{FF2B5EF4-FFF2-40B4-BE49-F238E27FC236}">
-                <a16:creationId xmlns:a16="http://schemas.microsoft.com/office/drawing/2014/main" id="{8E29B58E-3EB2-447F-91DC-780D7CD498B0}"/>
+                <a16:creationId xmlns:a16="http://schemas.microsoft.com/office/drawing/2014/main" id="{6DABE690-0608-40D0-BC8C-57D78A88B8CB}"/>
               </a:ext>
             </a:extLst>
           </p:cNvPr>
@@ -3392,12 +3392,12 @@
   </p:cSld>
   <p:clrMap bg1="lt1" tx1="dk1" bg2="lt2" tx2="dk2" accent1="accent1" accent2="accent2" accent3="accent3" accent4="accent4" accent5="accent5" accent6="accent6" hlink="hlink" folHlink="folHlink"/>
   <p:sldLayoutIdLst>
-    <p:sldLayoutId xmlns:r="http://schemas.openxmlformats.org/officeDocument/2006/relationships" id="2147483649" r:id="R02b3d7c5c62648ed"/>
-    <p:sldLayoutId xmlns:r="http://schemas.openxmlformats.org/officeDocument/2006/relationships" id="2147483650" r:id="R96486f30e2d4408d"/>
-    <p:sldLayoutId xmlns:r="http://schemas.openxmlformats.org/officeDocument/2006/relationships" id="2147483651" r:id="Rfd89c66578914c30"/>
-    <p:sldLayoutId xmlns:r="http://schemas.openxmlformats.org/officeDocument/2006/relationships" id="2147483652" r:id="Rf26921bd17e04e6e"/>
-    <p:sldLayoutId xmlns:r="http://schemas.openxmlformats.org/officeDocument/2006/relationships" id="2147483653" r:id="R0f4f57b496504609"/>
-    <p:sldLayoutId xmlns:r="http://schemas.openxmlformats.org/officeDocument/2006/relationships" id="2147483654" r:id="R7b1e61f7490f4a94"/>
+    <p:sldLayoutId xmlns:r="http://schemas.openxmlformats.org/officeDocument/2006/relationships" id="2147483649" r:id="R7fbb7129b6d84031"/>
+    <p:sldLayoutId xmlns:r="http://schemas.openxmlformats.org/officeDocument/2006/relationships" id="2147483650" r:id="R8b9977f8c7304f4b"/>
+    <p:sldLayoutId xmlns:r="http://schemas.openxmlformats.org/officeDocument/2006/relationships" id="2147483651" r:id="R547c19e93e064846"/>
+    <p:sldLayoutId xmlns:r="http://schemas.openxmlformats.org/officeDocument/2006/relationships" id="2147483652" r:id="R739aa562863445a3"/>
+    <p:sldLayoutId xmlns:r="http://schemas.openxmlformats.org/officeDocument/2006/relationships" id="2147483653" r:id="R199e4fb68d9047c6"/>
+    <p:sldLayoutId xmlns:r="http://schemas.openxmlformats.org/officeDocument/2006/relationships" id="2147483654" r:id="R819b8ac3c282458d"/>
   </p:sldLayoutIdLst>
   <p:txStyles>
     <p:titleStyle>
@@ -3948,7 +3948,7 @@
           <p:cNvPr id="3" name="titulo">
             <a:extLst xmlns:a="http://schemas.openxmlformats.org/drawingml/2006/main">
               <a:ext uri="{FF2B5EF4-FFF2-40B4-BE49-F238E27FC236}">
-                <a16:creationId xmlns:a16="http://schemas.microsoft.com/office/drawing/2014/main" id="{88D4E011-E18B-4DC5-8855-C501EC2C0EFF}"/>
+                <a16:creationId xmlns:a16="http://schemas.microsoft.com/office/drawing/2014/main" id="{2FD317ED-BE30-4818-B306-73F82854C62F}"/>
               </a:ext>
             </a:extLst>
           </p:cNvPr>
@@ -4105,7 +4105,7 @@
           <p:cNvPr id="2" name="conteudo">
             <a:extLst xmlns:a="http://schemas.openxmlformats.org/drawingml/2006/main">
               <a:ext uri="{FF2B5EF4-FFF2-40B4-BE49-F238E27FC236}">
-                <a16:creationId xmlns:a16="http://schemas.microsoft.com/office/drawing/2014/main" id="{B432424A-7B98-4A05-A0F4-0DAE873D4384}"/>
+                <a16:creationId xmlns:a16="http://schemas.microsoft.com/office/drawing/2014/main" id="{9EE33E40-445B-4649-AF53-F4B0D3A91A3F}"/>
               </a:ext>
             </a:extLst>
           </p:cNvPr>
@@ -4283,7 +4283,7 @@
     </p:spTree>
     <p:extLst>
       <p:ext uri="{BB962C8B-B14F-4D97-AF65-F5344CB8AC3E}">
-        <p14:creationId xmlns:p14="http://schemas.microsoft.com/office/powerpoint/2010/main" val="1795267985"/>
+        <p14:creationId xmlns:p14="http://schemas.microsoft.com/office/powerpoint/2010/main" val="132046052"/>
       </p:ext>
     </p:extLst>
   </p:cSld>
@@ -4314,7 +4314,7 @@
           <p:cNvPr id="4" name="titulo">
             <a:extLst xmlns:a="http://schemas.openxmlformats.org/drawingml/2006/main">
               <a:ext uri="{FF2B5EF4-FFF2-40B4-BE49-F238E27FC236}">
-                <a16:creationId xmlns:a16="http://schemas.microsoft.com/office/drawing/2014/main" id="{924BA6E3-7CD1-4853-AA5D-ED3E8F36FAF8}"/>
+                <a16:creationId xmlns:a16="http://schemas.microsoft.com/office/drawing/2014/main" id="{35E6F7E8-860A-4528-A482-83D846177892}"/>
               </a:ext>
             </a:extLst>
           </p:cNvPr>
@@ -4471,7 +4471,7 @@
           <p:cNvPr id="2" name="conteudo">
             <a:extLst xmlns:a="http://schemas.openxmlformats.org/drawingml/2006/main">
               <a:ext uri="{FF2B5EF4-FFF2-40B4-BE49-F238E27FC236}">
-                <a16:creationId xmlns:a16="http://schemas.microsoft.com/office/drawing/2014/main" id="{ABD4C1D7-9652-4892-A715-6791A9E6A2CF}"/>
+                <a16:creationId xmlns:a16="http://schemas.microsoft.com/office/drawing/2014/main" id="{480F6B07-DB6C-4D1E-A156-C1E7386119E1}"/>
               </a:ext>
             </a:extLst>
           </p:cNvPr>
@@ -4697,7 +4697,7 @@
           <p:cNvPr id="3" name="pagina">
             <a:extLst xmlns:a="http://schemas.openxmlformats.org/drawingml/2006/main">
               <a:ext uri="{FF2B5EF4-FFF2-40B4-BE49-F238E27FC236}">
-                <a16:creationId xmlns:a16="http://schemas.microsoft.com/office/drawing/2014/main" id="{621465FE-CF89-45C9-97BF-6BACADF8A0EF}"/>
+                <a16:creationId xmlns:a16="http://schemas.microsoft.com/office/drawing/2014/main" id="{36A60AF7-482C-458B-8584-D6D51132C068}"/>
               </a:ext>
             </a:extLst>
           </p:cNvPr>
@@ -4852,7 +4852,7 @@
     </p:spTree>
     <p:extLst>
       <p:ext uri="{BB962C8B-B14F-4D97-AF65-F5344CB8AC3E}">
-        <p14:creationId xmlns:p14="http://schemas.microsoft.com/office/powerpoint/2010/main" val="790991697"/>
+        <p14:creationId xmlns:p14="http://schemas.microsoft.com/office/powerpoint/2010/main" val="1290938299"/>
       </p:ext>
     </p:extLst>
   </p:cSld>
@@ -4883,7 +4883,7 @@
           <p:cNvPr id="4" name="titulo">
             <a:extLst xmlns:a="http://schemas.openxmlformats.org/drawingml/2006/main">
               <a:ext uri="{FF2B5EF4-FFF2-40B4-BE49-F238E27FC236}">
-                <a16:creationId xmlns:a16="http://schemas.microsoft.com/office/drawing/2014/main" id="{CB9530AF-7042-4364-A248-396DD117AF6D}"/>
+                <a16:creationId xmlns:a16="http://schemas.microsoft.com/office/drawing/2014/main" id="{269D421A-91DB-4D96-A771-DB92CCE42636}"/>
               </a:ext>
             </a:extLst>
           </p:cNvPr>
@@ -5040,7 +5040,7 @@
           <p:cNvPr id="2" name="conteudo">
             <a:extLst xmlns:a="http://schemas.openxmlformats.org/drawingml/2006/main">
               <a:ext uri="{FF2B5EF4-FFF2-40B4-BE49-F238E27FC236}">
-                <a16:creationId xmlns:a16="http://schemas.microsoft.com/office/drawing/2014/main" id="{F69E852E-F968-42D5-A83D-41E9C0260DBA}"/>
+                <a16:creationId xmlns:a16="http://schemas.microsoft.com/office/drawing/2014/main" id="{F32F1AEF-CD9F-4F43-8B08-FBDDB8E970A4}"/>
               </a:ext>
             </a:extLst>
           </p:cNvPr>
@@ -5289,7 +5289,7 @@
           <p:cNvPr id="3" name="pagina">
             <a:extLst xmlns:a="http://schemas.openxmlformats.org/drawingml/2006/main">
               <a:ext uri="{FF2B5EF4-FFF2-40B4-BE49-F238E27FC236}">
-                <a16:creationId xmlns:a16="http://schemas.microsoft.com/office/drawing/2014/main" id="{4FE794FB-D88A-466C-9C53-3E159F7FD6B4}"/>
+                <a16:creationId xmlns:a16="http://schemas.microsoft.com/office/drawing/2014/main" id="{7D4C6D5C-D845-45D9-9B22-CF1B0B489A19}"/>
               </a:ext>
             </a:extLst>
           </p:cNvPr>
@@ -5444,7 +5444,7 @@
     </p:spTree>
     <p:extLst>
       <p:ext uri="{BB962C8B-B14F-4D97-AF65-F5344CB8AC3E}">
-        <p14:creationId xmlns:p14="http://schemas.microsoft.com/office/powerpoint/2010/main" val="750168528"/>
+        <p14:creationId xmlns:p14="http://schemas.microsoft.com/office/powerpoint/2010/main" val="1060784615"/>
       </p:ext>
     </p:extLst>
   </p:cSld>
@@ -5475,7 +5475,7 @@
           <p:cNvPr id="4" name="titulo">
             <a:extLst xmlns:a="http://schemas.openxmlformats.org/drawingml/2006/main">
               <a:ext uri="{FF2B5EF4-FFF2-40B4-BE49-F238E27FC236}">
-                <a16:creationId xmlns:a16="http://schemas.microsoft.com/office/drawing/2014/main" id="{7B845EA5-A109-4F68-9B61-7451A61AEBAB}"/>
+                <a16:creationId xmlns:a16="http://schemas.microsoft.com/office/drawing/2014/main" id="{7DACE788-9808-44EF-BE6C-40723017999E}"/>
               </a:ext>
             </a:extLst>
           </p:cNvPr>
@@ -5632,7 +5632,7 @@
           <p:cNvPr id="2" name="conteudo">
             <a:extLst xmlns:a="http://schemas.openxmlformats.org/drawingml/2006/main">
               <a:ext uri="{FF2B5EF4-FFF2-40B4-BE49-F238E27FC236}">
-                <a16:creationId xmlns:a16="http://schemas.microsoft.com/office/drawing/2014/main" id="{A3E4B791-BD15-445C-8452-C60B43293537}"/>
+                <a16:creationId xmlns:a16="http://schemas.microsoft.com/office/drawing/2014/main" id="{30E4BA74-B8E6-4A95-B345-5A829B241833}"/>
               </a:ext>
             </a:extLst>
           </p:cNvPr>
@@ -5858,7 +5858,7 @@
           <p:cNvPr id="3" name="pagina">
             <a:extLst xmlns:a="http://schemas.openxmlformats.org/drawingml/2006/main">
               <a:ext uri="{FF2B5EF4-FFF2-40B4-BE49-F238E27FC236}">
-                <a16:creationId xmlns:a16="http://schemas.microsoft.com/office/drawing/2014/main" id="{C4A3FDE1-7882-4293-8BA4-D205558A5509}"/>
+                <a16:creationId xmlns:a16="http://schemas.microsoft.com/office/drawing/2014/main" id="{A0829FC5-AA7C-4FAF-862C-9E2B69FE432F}"/>
               </a:ext>
             </a:extLst>
           </p:cNvPr>
@@ -6013,7 +6013,7 @@
     </p:spTree>
     <p:extLst>
       <p:ext uri="{BB962C8B-B14F-4D97-AF65-F5344CB8AC3E}">
-        <p14:creationId xmlns:p14="http://schemas.microsoft.com/office/powerpoint/2010/main" val="891086700"/>
+        <p14:creationId xmlns:p14="http://schemas.microsoft.com/office/powerpoint/2010/main" val="1626184741"/>
       </p:ext>
     </p:extLst>
   </p:cSld>
@@ -6044,7 +6044,7 @@
           <p:cNvPr id="4" name="titulo">
             <a:extLst xmlns:a="http://schemas.openxmlformats.org/drawingml/2006/main">
               <a:ext uri="{FF2B5EF4-FFF2-40B4-BE49-F238E27FC236}">
-                <a16:creationId xmlns:a16="http://schemas.microsoft.com/office/drawing/2014/main" id="{1589E622-2FDB-4056-A151-D37A331B0A03}"/>
+                <a16:creationId xmlns:a16="http://schemas.microsoft.com/office/drawing/2014/main" id="{57FE775D-C2CC-4003-870D-1320A2CDE0E9}"/>
               </a:ext>
             </a:extLst>
           </p:cNvPr>
@@ -6201,7 +6201,7 @@
           <p:cNvPr id="2" name="conteudo">
             <a:extLst xmlns:a="http://schemas.openxmlformats.org/drawingml/2006/main">
               <a:ext uri="{FF2B5EF4-FFF2-40B4-BE49-F238E27FC236}">
-                <a16:creationId xmlns:a16="http://schemas.microsoft.com/office/drawing/2014/main" id="{B4671A11-E1CE-4249-8787-2CCE1BBCA759}"/>
+                <a16:creationId xmlns:a16="http://schemas.microsoft.com/office/drawing/2014/main" id="{A42942BC-4220-4393-86F6-94FF113B1936}"/>
               </a:ext>
             </a:extLst>
           </p:cNvPr>
@@ -6348,7 +6348,7 @@
                 <a:ea typeface="DejaVu Sans"/>
                 <a:cs typeface="DejaVu Sans"/>
               </a:rPr>
-              <a:t>Blueprint do Render preparado no repositório.</a:t>
+              <a:t>API publicada por Docker no Render.</a:t>
             </a:r>
           </a:p>
           <a:p xmlns:a="http://schemas.openxmlformats.org/drawingml/2006/main">
@@ -6371,7 +6371,7 @@
                 <a:ea typeface="DejaVu Sans"/>
                 <a:cs typeface="DejaVu Sans"/>
               </a:rPr>
-              <a:t>A API lê a porta do provedor e oferece /health.</a:t>
+              <a:t>https://prato-cheio-cp3.onrender.com</a:t>
             </a:r>
           </a:p>
           <a:p xmlns:a="http://schemas.openxmlformats.org/drawingml/2006/main">
@@ -6394,7 +6394,7 @@
                 <a:ea typeface="DejaVu Sans"/>
                 <a:cs typeface="DejaVu Sans"/>
               </a:rPr>
-              <a:t>A publicação e a URL HTTPS dependem de autenticação.</a:t>
+              <a:t>12 requisições HTTPS aprovadas no fluxo principal.</a:t>
             </a:r>
           </a:p>
           <a:p xmlns:a="http://schemas.openxmlformats.org/drawingml/2006/main">
@@ -6427,7 +6427,7 @@
           <p:cNvPr id="3" name="pagina">
             <a:extLst xmlns:a="http://schemas.openxmlformats.org/drawingml/2006/main">
               <a:ext uri="{FF2B5EF4-FFF2-40B4-BE49-F238E27FC236}">
-                <a16:creationId xmlns:a16="http://schemas.microsoft.com/office/drawing/2014/main" id="{856E9403-3191-4A0A-B270-CDFF1D2CF3EE}"/>
+                <a16:creationId xmlns:a16="http://schemas.microsoft.com/office/drawing/2014/main" id="{4C880A41-CA9F-4D75-AF46-86CB55B3B14F}"/>
               </a:ext>
             </a:extLst>
           </p:cNvPr>
@@ -6582,7 +6582,7 @@
     </p:spTree>
     <p:extLst>
       <p:ext uri="{BB962C8B-B14F-4D97-AF65-F5344CB8AC3E}">
-        <p14:creationId xmlns:p14="http://schemas.microsoft.com/office/powerpoint/2010/main" val="1151467193"/>
+        <p14:creationId xmlns:p14="http://schemas.microsoft.com/office/powerpoint/2010/main" val="1633917564"/>
       </p:ext>
     </p:extLst>
   </p:cSld>
@@ -6613,7 +6613,7 @@
           <p:cNvPr id="4" name="titulo">
             <a:extLst xmlns:a="http://schemas.openxmlformats.org/drawingml/2006/main">
               <a:ext uri="{FF2B5EF4-FFF2-40B4-BE49-F238E27FC236}">
-                <a16:creationId xmlns:a16="http://schemas.microsoft.com/office/drawing/2014/main" id="{B62A8655-F853-421E-A755-D3BB6C287A4E}"/>
+                <a16:creationId xmlns:a16="http://schemas.microsoft.com/office/drawing/2014/main" id="{980BFEB3-AFF1-4CFD-9506-BF1C72864756}"/>
               </a:ext>
             </a:extLst>
           </p:cNvPr>
@@ -6770,7 +6770,7 @@
           <p:cNvPr id="2" name="conteudo">
             <a:extLst xmlns:a="http://schemas.openxmlformats.org/drawingml/2006/main">
               <a:ext uri="{FF2B5EF4-FFF2-40B4-BE49-F238E27FC236}">
-                <a16:creationId xmlns:a16="http://schemas.microsoft.com/office/drawing/2014/main" id="{D5BBF5EE-7DA4-4585-AB3E-58F45BCA5EA5}"/>
+                <a16:creationId xmlns:a16="http://schemas.microsoft.com/office/drawing/2014/main" id="{DF3FE8A3-0D46-42B0-9CA2-28FA9859F263}"/>
               </a:ext>
             </a:extLst>
           </p:cNvPr>
@@ -6996,7 +6996,7 @@
           <p:cNvPr id="3" name="pagina">
             <a:extLst xmlns:a="http://schemas.openxmlformats.org/drawingml/2006/main">
               <a:ext uri="{FF2B5EF4-FFF2-40B4-BE49-F238E27FC236}">
-                <a16:creationId xmlns:a16="http://schemas.microsoft.com/office/drawing/2014/main" id="{E4E743EA-5CB4-4916-ACCA-EEF823088997}"/>
+                <a16:creationId xmlns:a16="http://schemas.microsoft.com/office/drawing/2014/main" id="{ED2AC7EE-18C1-427E-8018-1B56BF242923}"/>
               </a:ext>
             </a:extLst>
           </p:cNvPr>
@@ -7151,7 +7151,7 @@
     </p:spTree>
     <p:extLst>
       <p:ext uri="{BB962C8B-B14F-4D97-AF65-F5344CB8AC3E}">
-        <p14:creationId xmlns:p14="http://schemas.microsoft.com/office/powerpoint/2010/main" val="2023094289"/>
+        <p14:creationId xmlns:p14="http://schemas.microsoft.com/office/powerpoint/2010/main" val="69844747"/>
       </p:ext>
     </p:extLst>
   </p:cSld>
@@ -7182,7 +7182,7 @@
           <p:cNvPr id="4" name="titulo">
             <a:extLst xmlns:a="http://schemas.openxmlformats.org/drawingml/2006/main">
               <a:ext uri="{FF2B5EF4-FFF2-40B4-BE49-F238E27FC236}">
-                <a16:creationId xmlns:a16="http://schemas.microsoft.com/office/drawing/2014/main" id="{614DA978-18FF-4163-864D-64687867559A}"/>
+                <a16:creationId xmlns:a16="http://schemas.microsoft.com/office/drawing/2014/main" id="{BEA2E854-798F-45F4-9C5A-4272C84539A3}"/>
               </a:ext>
             </a:extLst>
           </p:cNvPr>
@@ -7339,7 +7339,7 @@
           <p:cNvPr id="2" name="conteudo">
             <a:extLst xmlns:a="http://schemas.openxmlformats.org/drawingml/2006/main">
               <a:ext uri="{FF2B5EF4-FFF2-40B4-BE49-F238E27FC236}">
-                <a16:creationId xmlns:a16="http://schemas.microsoft.com/office/drawing/2014/main" id="{91984645-E132-4035-9745-C0BBD6269778}"/>
+                <a16:creationId xmlns:a16="http://schemas.microsoft.com/office/drawing/2014/main" id="{D20F04AE-D5FF-4C8C-9CD7-329CDA3F513D}"/>
               </a:ext>
             </a:extLst>
           </p:cNvPr>
@@ -7565,7 +7565,7 @@
           <p:cNvPr id="3" name="pagina">
             <a:extLst xmlns:a="http://schemas.openxmlformats.org/drawingml/2006/main">
               <a:ext uri="{FF2B5EF4-FFF2-40B4-BE49-F238E27FC236}">
-                <a16:creationId xmlns:a16="http://schemas.microsoft.com/office/drawing/2014/main" id="{BC4356E5-101C-420D-BC09-A04B1C162628}"/>
+                <a16:creationId xmlns:a16="http://schemas.microsoft.com/office/drawing/2014/main" id="{CDD3EA9E-A2B6-4A8E-8043-34190D28541F}"/>
               </a:ext>
             </a:extLst>
           </p:cNvPr>
@@ -7720,7 +7720,7 @@
     </p:spTree>
     <p:extLst>
       <p:ext uri="{BB962C8B-B14F-4D97-AF65-F5344CB8AC3E}">
-        <p14:creationId xmlns:p14="http://schemas.microsoft.com/office/powerpoint/2010/main" val="210741601"/>
+        <p14:creationId xmlns:p14="http://schemas.microsoft.com/office/powerpoint/2010/main" val="1607765364"/>
       </p:ext>
     </p:extLst>
   </p:cSld>
@@ -7751,7 +7751,7 @@
           <p:cNvPr id="4" name="titulo">
             <a:extLst xmlns:a="http://schemas.openxmlformats.org/drawingml/2006/main">
               <a:ext uri="{FF2B5EF4-FFF2-40B4-BE49-F238E27FC236}">
-                <a16:creationId xmlns:a16="http://schemas.microsoft.com/office/drawing/2014/main" id="{0E42FC4E-BFAE-4080-B54F-5F3AE7729BAE}"/>
+                <a16:creationId xmlns:a16="http://schemas.microsoft.com/office/drawing/2014/main" id="{C5EE2F0F-C2CE-41B9-A6DD-35D9D0BCF247}"/>
               </a:ext>
             </a:extLst>
           </p:cNvPr>
@@ -7908,7 +7908,7 @@
           <p:cNvPr id="2" name="conteudo">
             <a:extLst xmlns:a="http://schemas.openxmlformats.org/drawingml/2006/main">
               <a:ext uri="{FF2B5EF4-FFF2-40B4-BE49-F238E27FC236}">
-                <a16:creationId xmlns:a16="http://schemas.microsoft.com/office/drawing/2014/main" id="{8D24983B-6F53-461E-8C9F-44D48678F2B6}"/>
+                <a16:creationId xmlns:a16="http://schemas.microsoft.com/office/drawing/2014/main" id="{83CE3030-7B8B-4964-BA21-573F72DC6CA4}"/>
               </a:ext>
             </a:extLst>
           </p:cNvPr>
@@ -8134,7 +8134,7 @@
           <p:cNvPr id="3" name="pagina">
             <a:extLst xmlns:a="http://schemas.openxmlformats.org/drawingml/2006/main">
               <a:ext uri="{FF2B5EF4-FFF2-40B4-BE49-F238E27FC236}">
-                <a16:creationId xmlns:a16="http://schemas.microsoft.com/office/drawing/2014/main" id="{40BD25E7-C07E-40D9-8961-93EEE7852FAB}"/>
+                <a16:creationId xmlns:a16="http://schemas.microsoft.com/office/drawing/2014/main" id="{A5826FAE-347C-4075-86A2-76C4A306E87C}"/>
               </a:ext>
             </a:extLst>
           </p:cNvPr>
@@ -8289,7 +8289,7 @@
     </p:spTree>
     <p:extLst>
       <p:ext uri="{BB962C8B-B14F-4D97-AF65-F5344CB8AC3E}">
-        <p14:creationId xmlns:p14="http://schemas.microsoft.com/office/powerpoint/2010/main" val="427387354"/>
+        <p14:creationId xmlns:p14="http://schemas.microsoft.com/office/powerpoint/2010/main" val="841550035"/>
       </p:ext>
     </p:extLst>
   </p:cSld>

</xml_diff>